<commit_message>
Keep M10 methods out of M09 close
Co-authored-by: shaseaver25 <shannon@tailoredu.org>
</commit_message>
<xml_diff>
--- a/teaching-pack/13-M09-false-precision/M09-student.pptx
+++ b/teaching-pack/13-M09-false-precision/M09-student.pptx
@@ -6836,7 +6836,7 @@
                 </a:solidFill>
                 <a:latin typeface="Arial"/>
               </a:rPr>
-              <a:t>Do not replace one unsupported exact number with a formal interval; that method begins in M10.</a:t>
+              <a:t>Do not replace one unsupported exact number with a method the class has not learned yet.</a:t>
             </a:r>
           </a:p>
         </p:txBody>
@@ -9498,7 +9498,7 @@
                 </a:solidFill>
                 <a:latin typeface="Arial"/>
               </a:rPr>
-              <a:t>No formal interval or significance test is required today.</a:t>
+              <a:t>Use only today's precision, spread, and sampling evidence.</a:t>
             </a:r>
           </a:p>
         </p:txBody>

</xml_diff>